<commit_message>
Slide 3 shows rating counts; 'helpful votes' replaces the thumbs-up emoji
Co-Authored-By: Claude Opus 5.5 <noreply@anthropic.com>
</commit_message>
<xml_diff>
--- a/docs/deck.pptx
+++ b/docs/deck.pptx
@@ -115,13 +115,13 @@
   <p:extLst>
     <p:ext uri="{521415D9-36F7-43E2-AB2F-B90AF26B5E84}">
       <p14:sectionLst xmlns:p14="http://schemas.microsoft.com/office/powerpoint/2010/main">
-        <p14:section name="Answer" id="{cb3f4bb0-f40b-16cf-0d05-f76cfbb1dd2f}">
+        <p14:section name="Answer" id="{c93098bb-bd6f-625b-d16e-7d2f9087c61c}">
           <p14:sldIdLst>
             <p14:sldId id="256"/>
             <p14:sldId id="257"/>
           </p14:sldIdLst>
         </p14:section>
-        <p14:section name="Diagnosis" id="{1735c509-b5c3-50e3-505c-4ab6304a39b0}">
+        <p14:section name="Diagnosis" id="{116d29e3-9177-3849-37ca-e632dfe7c1ed}">
           <p14:sldIdLst>
             <p14:sldId id="258"/>
             <p14:sldId id="259"/>
@@ -130,7 +130,7 @@
             <p14:sldId id="262"/>
           </p14:sldIdLst>
         </p14:section>
-        <p14:section name="Plan" id="{7bc25594-991c-84f9-bfa3-4ec72d7a1d02}">
+        <p14:section name="Plan" id="{d984a520-f506-8ed7-47fe-8208f4094a34}">
           <p14:sldIdLst>
             <p14:sldId id="263"/>
             <p14:sldId id="264"/>
@@ -171,7 +171,7 @@
                 </a:solidFill>
                 <a:latin typeface="+mn-lt"/>
               </a:rPr>
-              <a:t>Play Store rating, India storefront</a:t>
+              <a:t>Play Store rating, India storefront (number of ratings)</a:t>
             </a:r>
           </a:p>
         </c:rich>
@@ -326,28 +326,28 @@
                 <c:ptCount val="8"/>
                 <c:lvl>
                   <c:pt idx="0">
-                    <c:v>COMMUTE (Proficio)</c:v>
+                    <c:v>COMMUTE, Proficio (609)</c:v>
                   </c:pt>
                   <c:pt idx="1">
-                    <c:v>eFmFm Employee</c:v>
+                    <c:v>eFmFm Employee (4.9K)</c:v>
                   </c:pt>
                   <c:pt idx="2">
-                    <c:v>SMT Employee</c:v>
+                    <c:v>SMT Employee (835)</c:v>
                   </c:pt>
                   <c:pt idx="3">
-                    <c:v>NeOffice Commute</c:v>
+                    <c:v>NeOffice Commute (253)</c:v>
                   </c:pt>
                   <c:pt idx="4">
-                    <c:v>Routematic</c:v>
+                    <c:v>Routematic (35K)</c:v>
                   </c:pt>
                   <c:pt idx="5">
-                    <c:v>Safetrax (older app)</c:v>
+                    <c:v>Safetrax, older app (1.1K)</c:v>
                   </c:pt>
                   <c:pt idx="6">
-                    <c:v>MoveInSync</c:v>
+                    <c:v>MoveInSync (115K)</c:v>
                   </c:pt>
                   <c:pt idx="7">
-                    <c:v>Safetrax Commuter</c:v>
+                    <c:v>Safetrax Commuter (24K)</c:v>
                   </c:pt>
                 </c:lvl>
               </c:multiLvlStrCache>
@@ -2639,7 +2639,7 @@
           <a:p>
             <a:r>
               <a:rPr lang="en-US" dirty="0"/>
-              <a:t>Here's the benchmark against seven other employee-commute apps. MoveInSync is second, just behind Safetrax Commuter, and it has more ratings than the other seven combined. The Play Store rounds to one decimal, so 4.639 shows as 4.6. Crossing 4.65 flips the display to 4.7. One trap worth knowing: ratings are per country. The same app shows 4.3 in the US.</a:t>
+              <a:t>Here's the benchmark against seven other employee-commute apps. MoveInSync is second, 0.08 behind Safetrax Commuter, but on nearly five times the ratings: 115 thousand against 24 thousand. Safetrax had just 114 written reviews last year; MoveInSync had 2,848. MoveInSync has more ratings than the other seven combined. The Play Store rounds to one decimal, so 4.639 shows as 4.6. Crossing 4.65 flips the display to 4.7. One trap worth knowing: ratings are per country. The same app shows 4.3 in the US.</a:t>
             </a:r>
             <a:endParaRPr lang="en-US" dirty="0"/>
           </a:p>
@@ -5250,7 +5250,7 @@
                   <a:schemeClr val="tx2"/>
                 </a:solidFill>
               </a:rPr>
-              <a:t>ratings: more than the other seven apps combined</a:t>
+              <a:t>ratings: nearly 5× Safetrax's, and more than the other seven combined</a:t>
             </a:r>
             <a:endParaRPr lang="en-US" sz="1400" dirty="0"/>
           </a:p>

</xml_diff>

<commit_message>
Deck notes: open with the answer, method line moved to the close
Co-Authored-By: Claude Opus 5.5 <noreply@anthropic.com>
</commit_message>
<xml_diff>
--- a/docs/deck.pptx
+++ b/docs/deck.pptx
@@ -115,13 +115,13 @@
   <p:extLst>
     <p:ext uri="{521415D9-36F7-43E2-AB2F-B90AF26B5E84}">
       <p14:sectionLst xmlns:p14="http://schemas.microsoft.com/office/powerpoint/2010/main">
-        <p14:section name="Answer" id="{c93098bb-bd6f-625b-d16e-7d2f9087c61c}">
+        <p14:section name="Answer" id="{997a584e-25ce-1548-3ee7-a27daf908586}">
           <p14:sldIdLst>
             <p14:sldId id="256"/>
             <p14:sldId id="257"/>
           </p14:sldIdLst>
         </p14:section>
-        <p14:section name="Diagnosis" id="{116d29e3-9177-3849-37ca-e632dfe7c1ed}">
+        <p14:section name="Diagnosis" id="{9c2ccffc-e5af-c43a-5535-2bb8af0628f4}">
           <p14:sldIdLst>
             <p14:sldId id="258"/>
             <p14:sldId id="259"/>
@@ -130,7 +130,7 @@
             <p14:sldId id="262"/>
           </p14:sldIdLst>
         </p14:section>
-        <p14:section name="Plan" id="{d984a520-f506-8ed7-47fe-8208f4094a34}">
+        <p14:section name="Plan" id="{f43f0970-377a-d02d-14c0-669b7361c27f}">
           <p14:sldIdLst>
             <p14:sldId id="263"/>
             <p14:sldId id="264"/>
@@ -2463,7 +2463,7 @@
           <a:p>
             <a:r>
               <a:rPr lang="en-US" dirty="0"/>
-              <a:t>MoveInSync asked why its Play Store ratings are lower than they should be, and what to fix first. I pulled every public review of the employee app, 24,315 of them, labelled 1,400 with AI using a versioned prompt, had a person audit the labels at 94% accuracy, and built a monitor that keeps answering the question every week. Here's what I found and what I'd do.</a:t>
+              <a:t>Hi, I'm Abhijit Kumar, and this is my recommendation for MoveInSync's Play Store ratings. The short version: the store number isn't really the problem. What people read is, and it's mostly the app, not the cabs. I'll show the evidence, then exactly what I'd fix first.</a:t>
             </a:r>
             <a:endParaRPr lang="en-US" dirty="0"/>
           </a:p>
@@ -3167,7 +3167,7 @@
           <a:p>
             <a:r>
               <a:rPr lang="en-US" dirty="0"/>
-              <a:t>Finally, 'how are our ratings?' is now answered automatically. Every day a scheduled job records the store rating, labels new reviews and refreshes the dashboard. Every week the answer is posted as a GitHub Issue, with an alert if a release regresses. Safety reports and unclear reviews go to a person. It runs free on keyword rules, or for about two cents a week with Claude Sonnet. The AI labels were 94 percent right in a human audit. Thank you.</a:t>
+              <a:t>Finally, 'how are our ratings?' is now answered automatically. Every day a scheduled job records the store rating, labels new reviews and refreshes the dashboard. Every week the answer is posted as a GitHub Issue, with an alert if a release regresses. Safety reports and unclear reviews go to a person. It runs free on keyword rules, or for about two cents a week with Claude Sonnet. Behind all of this: 24,315 public reviews, 1,400 labelled with AI, and a human audit that found the labels 94 percent right. Everything is in the repository. Thank you.</a:t>
             </a:r>
             <a:endParaRPr lang="en-US" dirty="0"/>
           </a:p>

</xml_diff>